<commit_message>
docs(report): regenerate report docx and slides pptx with decree 30 formatting and integrate member contributions
</commit_message>
<xml_diff>
--- a/docs/Slide_Bao_Cao_He_Thong_Dat_Lich_Salon_Spa.pptx
+++ b/docs/Slide_Bao_Cao_He_Thong_Dat_Lich_Salon_Spa.pptx
@@ -225,11 +225,11 @@
           <c:showLeaderLines val="1"/>
         </c:dLbls>
         <c:gapWidth val="55"/>
-        <c:axId val="-2068027336"/>
-        <c:axId val="-2113994440"/>
+        <c:axId val="2226939960"/>
+        <c:axId val="2180972856"/>
       </c:barChart>
       <c:catAx>
-        <c:axId val="-2068027336"/>
+        <c:axId val="2226939960"/>
         <c:scaling>
           <c:orientation val="minMax"/>
         </c:scaling>
@@ -258,7 +258,7 @@
             </a:pPr>
           </a:p>
         </c:txPr>
-        <c:crossAx val="-2113994440"/>
+        <c:crossAx val="2180972856"/>
         <c:crosses val="autoZero"/>
         <c:auto val="1"/>
         <c:lblAlgn val="ctr"/>
@@ -266,7 +266,7 @@
         <c:noMultiLvlLbl val="0"/>
       </c:catAx>
       <c:valAx>
-        <c:axId val="-2113994440"/>
+        <c:axId val="2180972856"/>
         <c:scaling>
           <c:max val="46.0"/>
         </c:scaling>
@@ -275,7 +275,7 @@
         <c:majorTickMark val="out"/>
         <c:minorTickMark val="none"/>
         <c:tickLblPos val="nextTo"/>
-        <c:crossAx val="-2068027336"/>
+        <c:crossAx val="2226939960"/>
         <c:crosses val="autoZero"/>
       </c:valAx>
     </c:plotArea>
@@ -762,7 +762,7 @@
           <a:lstStyle/>
           <a:p>
             <a:r>
-              <a:t>Mục tiêu: sao chép dự án sang bất kỳ máy nào, bật Docker Desktop, nhấp đúp run_project.bat. Launcher kiểm tra Node, dựng Docker, tạo .env, cài gói khi lockfile đổi, nạp dữ liệu an toàn, rồi bộ giám sát chạy API và giao diện. Bản v1.2.5 xử lý lỗi Windows 3221226505: dịch vụ sập được tự khởi động lại, Ctrl+C dừng sạch cả cây tiến trình.</a:t>
+              <a:t>Mục tiêu: sao chép dự án sang bất kỳ máy nào, bật Docker Desktop, nhấp đúp run_project.bat. Launcher kiểm tra Node, dựng Docker, tạo .env, cài gói khi lockfile đổi, nạp dữ liệu an toàn, rồi bộ giám sát chạy API và giao diện. Bản v1.2.5 xử lý lỗi Windows 3221226505: dịch vụ sập được tự khởi động lại, Ctrl+C dừng sạch cả cây tiến trình. SSE phát sau commit; TypeORM migration có phiên bản và rollback bước lỗi. update_project.bat build bản mới, sao lưu trước migration, healthcheck; lỗi bật lại bản build cũ, giữ migration đã hoàn tất tương thích. Máy vận hành không seed dữ liệu mẫu.</a:t>
             </a:r>
           </a:p>
         </p:txBody>
@@ -832,7 +832,7 @@
           <a:lstStyle/>
           <a:p>
             <a:r>
-              <a:t>Chất lượng: 35 unit test cho bộ tính khung giờ, 25 E2E test gồm phân quyền, đồng thời và vòng đời lịch hẹn, đều đạt. Build và lint 0 lỗi, 0 cảnh báo. 39/39 story được đối chiếu với mã nguồn trong BACKLOG-MAPPING, làm căn cứ cập nhật Jira. Mọi phản hồi của PO đều được xử lý và phát hành thành phiên bản có tag.</a:t>
+              <a:t>Kiểm định 06/10/2026: 139 unit test, 83 E2E trong 12 bộ, 4 test Demo đạt. Build và lint sạch. 39 story / 165 point đối chiếu Excel gốc và BACKLOG-MAPPING; test tự động không thay thế biên bản nghiệm thu thủ công của PO.</a:t>
             </a:r>
           </a:p>
         </p:txBody>
@@ -1182,7 +1182,7 @@
           <a:lstStyle/>
           <a:p>
             <a:r>
-              <a:t>Thầy Cấn Tuấn Anh là Product Owner. Backlog có 6 epic, 39 story, 165 point. Sprint 1: 10 story 40 point, nền tảng tài khoản và danh mục. Sprint 2: 9 story 42 point, ca làm và đặt lịch công khai. Sprint 3 và 4 gồm 20 story, 83 point: vận hành trong ngày, thanh toán, đánh giá và báo cáo. EP-04 Vận hành lịch hẹn là epic lớn nhất. Mỗi Sprint kết thúc bằng Review có demo và PO nghiệm thu.</a:t>
+              <a:t>Thầy Cấn Tuấn Anh là Product Owner. Backlog có 6 epic, 39 story, 165 point. Sprint 1: 10 story 40 point, nền tảng tài khoản và danh mục. Sprint 2: 9 story 42 point, ca làm và đặt lịch công khai. Sprint 3: 10 story 42 point; Sprint 4: 10 story 41 point, theo Excel gốc. EP-04 Vận hành lịch hẹn là epic lớn nhất. Mỗi Sprint kết thúc bằng Review có demo và PO nghiệm thu.</a:t>
             </a:r>
           </a:p>
         </p:txBody>
@@ -1532,7 +1532,7 @@
           <a:lstStyle/>
           <a:p>
             <a:r>
-              <a:t>Chủ tiệm có tổng quan tự làm mới 60 giây, doanh thu theo thợ và dịch vụ, xuất CSV. Phiếu tính tiền lưu giá tại thời điểm hẹn, chỉ một mã giảm giá, phiếu đã đóng bị khoá – đây là cơ chế chống gian lận. Phân quyền theo ma trận 5 vai trò, cùng một nguồn dữ liệu cho cả giao diện và guard chặn API.</a:t>
+              <a:t>Chủ tiệm có tổng quan tự làm mới 60 giây, doanh thu theo thợ và dịch vụ, xuất CSV. Phiếu tính tiền lưu giá tại thời điểm hẹn, chỉ một mã giảm giá, phiếu đã đóng bị khoá – đây là cơ chế chống gian lận. Phân quyền theo 4 vai trò nhân sự và phạm vi khách công khai, cùng nguồn quyền cho giao diện và guard API.</a:t>
             </a:r>
           </a:p>
         </p:txBody>
@@ -5242,7 +5242,7 @@
                 </a:solidFill>
                 <a:latin typeface="Calibri"/>
               </a:rPr>
-              <a:t>Docker 1 lệnh · Supervisor tự phục hồi v1.2.5</a:t>
+              <a:t>SSE · TypeORM Migration · cập nhật một chạm</a:t>
             </a:r>
           </a:p>
         </p:txBody>
@@ -6298,7 +6298,7 @@
                 </a:solidFill>
                 <a:latin typeface="Calibri"/>
               </a:rPr>
-              <a:t>Seed an toàn</a:t>
+              <a:t>Migration</a:t>
             </a:r>
           </a:p>
         </p:txBody>
@@ -6340,7 +6340,7 @@
                 </a:solidFill>
                 <a:latin typeface="Calibri"/>
               </a:rPr>
-              <a:t>Chờ CSDL ≤ 120 s, schema + seed idempotent</a:t>
+              <a:t>Lược đồ có phiên bản; seed chỉ ở máy phát triển / QA</a:t>
             </a:r>
           </a:p>
         </p:txBody>
@@ -6717,7 +6717,7 @@
                 </a:solidFill>
                 <a:latin typeface="Calibri"/>
               </a:rPr>
-              <a:t>13–21 giây</a:t>
+              <a:t>SSE</a:t>
             </a:r>
           </a:p>
         </p:txBody>
@@ -6759,7 +6759,7 @@
                 </a:solidFill>
                 <a:latin typeface="Calibri"/>
               </a:rPr>
-              <a:t>từ lúc nhấp đúp đến khi trình duyệt mở (CSDL mới)</a:t>
+              <a:t>phát sự kiện sau commit, giao diện tải lại dữ liệu</a:t>
             </a:r>
           </a:p>
         </p:txBody>
@@ -6851,7 +6851,7 @@
                 </a:solidFill>
                 <a:latin typeface="Calibri"/>
               </a:rPr>
-              <a:t>~2 giây</a:t>
+              <a:t>Migration</a:t>
             </a:r>
           </a:p>
         </p:txBody>
@@ -6893,7 +6893,7 @@
                 </a:solidFill>
                 <a:latin typeface="Calibri"/>
               </a:rPr>
-              <a:t>tự khởi động lại khi Vite bị abort (mã 3221226505)</a:t>
+              <a:t>khoá nâng cấp; rollback bước lỗi; synchronize: false</a:t>
             </a:r>
           </a:p>
         </p:txBody>
@@ -6985,7 +6985,7 @@
                 </a:solidFill>
                 <a:latin typeface="Calibri"/>
               </a:rPr>
-              <a:t>0 thao tác tay</a:t>
+              <a:t>1-Click Update</a:t>
             </a:r>
           </a:p>
         </p:txBody>
@@ -7027,7 +7027,7 @@
                 </a:solidFill>
                 <a:latin typeface="Calibri"/>
               </a:rPr>
-              <a:t>tạo .env, cài gói, nạp dữ liệu, mở trình duyệt</a:t>
+              <a:t>build mới → sao lưu → migration → healthcheck</a:t>
             </a:r>
           </a:p>
         </p:txBody>
@@ -7074,7 +7074,7 @@
                 </a:solidFill>
                 <a:latin typeface="Calibri"/>
               </a:rPr>
-              <a:t>Seed idempotent: </a:t>
+              <a:t>Máy vận hành: </a:t>
             </a:r>
             <a:r>
               <a:rPr sz="1350" b="0">
@@ -7083,7 +7083,7 @@
                 </a:solidFill>
                 <a:latin typeface="Calibri"/>
               </a:rPr>
-              <a:t>ON CONFLICT DO NOTHING, bỏ qua khung giờ trùng lịch thật, reset 8 tài khoản mẫu mỗi lần chạy.</a:t>
+              <a:t>start_server.bat / update_project.bat; bootstrap, giữ dữ liệu khách, không nạp seed mẫu.</a:t>
             </a:r>
           </a:p>
           <a:p>
@@ -7402,7 +7402,7 @@
                 </a:solidFill>
                 <a:latin typeface="Calibri"/>
               </a:rPr>
-              <a:t>35 / 35</a:t>
+              <a:t>139/139</a:t>
             </a:r>
           </a:p>
         </p:txBody>
@@ -7486,7 +7486,7 @@
                 </a:solidFill>
                 <a:latin typeface="Calibri"/>
               </a:rPr>
-              <a:t>Bộ tính khung giờ</a:t>
+              <a:t>8 bộ kiểm thử nghiệp vụ</a:t>
             </a:r>
           </a:p>
         </p:txBody>
@@ -7578,7 +7578,7 @@
                 </a:solidFill>
                 <a:latin typeface="Calibri"/>
               </a:rPr>
-              <a:t>25 / 25</a:t>
+              <a:t>83/83</a:t>
             </a:r>
           </a:p>
         </p:txBody>
@@ -7662,7 +7662,7 @@
                 </a:solidFill>
                 <a:latin typeface="Calibri"/>
               </a:rPr>
-              <a:t>RBAC · đồng thời · vòng đời</a:t>
+              <a:t>12 bộ PostgreSQL · Demo 4/4</a:t>
             </a:r>
           </a:p>
         </p:txBody>
@@ -7972,7 +7972,7 @@
                 </a:solidFill>
                 <a:latin typeface="Calibri"/>
               </a:rPr>
-              <a:t>User story nghiệm thu</a:t>
+              <a:t>User story đối chiếu</a:t>
             </a:r>
           </a:p>
         </p:txBody>
@@ -8014,7 +8014,7 @@
                 </a:solidFill>
                 <a:latin typeface="Calibri"/>
               </a:rPr>
-              <a:t>BACKLOG-MAPPING ↔ Jira</a:t>
+              <a:t>4 Sprint · 165 Story Point</a:t>
             </a:r>
           </a:p>
         </p:txBody>
@@ -13544,7 +13544,7 @@
                 </a:solidFill>
                 <a:latin typeface="Calibri"/>
               </a:rPr>
-              <a:t>Monorepo phân tầng: React SPA ⇄ NestJS ⇄ PostgreSQL 15</a:t>
+              <a:t>4 tầng: React Vite ⇄ API ⇄ Nghiệp vụ ⇄ TypeORM / PostgreSQL</a:t>
             </a:r>
           </a:p>
         </p:txBody>
@@ -13769,7 +13769,7 @@
                 </a:solidFill>
                 <a:latin typeface="Calibri"/>
               </a:rPr>
-              <a:t>13 module nghiệp vụ, 59 endpoint REST, Swagger /api/docs</a:t>
+              <a:t>API và nghiệp vụ NestJS 10; TypeORM Migration; Swagger /api/docs</a:t>
             </a:r>
           </a:p>
         </p:txBody>
@@ -13920,7 +13920,7 @@
                 </a:solidFill>
                 <a:latin typeface="Calibri"/>
               </a:rPr>
-              <a:t>JWT + RBAC 5 vai trò; mọi endpoint mặc định phải đăng nhập</a:t>
+              <a:t>JWT + RBAC 4 vai trò nhân sự; khách dùng API công khai</a:t>
             </a:r>
           </a:p>
         </p:txBody>
@@ -14710,7 +14710,7 @@
                 </a:solidFill>
                 <a:latin typeface="Calibri"/>
               </a:rPr>
-              <a:t>100%</a:t>
+              <a:t>4</a:t>
             </a:r>
           </a:p>
         </p:txBody>
@@ -14752,7 +14752,7 @@
                 </a:solidFill>
                 <a:latin typeface="Calibri"/>
               </a:rPr>
-              <a:t>Hoàn thành</a:t>
+              <a:t>Sprint</a:t>
             </a:r>
           </a:p>
         </p:txBody>
@@ -15442,7 +15442,7 @@
                 </a:solidFill>
                 <a:latin typeface="Calibri"/>
               </a:rPr>
-              <a:t>83 pt</a:t>
+              <a:t>42 pt</a:t>
             </a:r>
           </a:p>
         </p:txBody>
@@ -15666,13 +15666,13 @@
               </a:spcAft>
             </a:pPr>
             <a:r>
-              <a:rPr sz="1200" b="0" i="0">
+              <a:rPr sz="1600" b="1" i="0">
                 <a:solidFill>
                   <a:srgbClr val="0F766E"/>
                 </a:solidFill>
                 <a:latin typeface="Calibri"/>
               </a:rPr>
-              <a:t>(S3 + S4)</a:t>
+              <a:t>41 pt</a:t>
             </a:r>
           </a:p>
         </p:txBody>
@@ -20101,7 +20101,7 @@
                 </a:solidFill>
                 <a:latin typeface="Calibri"/>
               </a:rPr>
-              <a:t>Hoá đơn – voucher, doanh thu realtime, RBAC 5 vai trò</a:t>
+              <a:t>Hoá đơn – voucher, doanh thu realtime, 4 vai trò nhân sự + khách</a:t>
             </a:r>
           </a:p>
         </p:txBody>

</xml_diff>

<commit_message>
docs(report): format report and slides according to decree 30/2020/ND-CP and synchronize 39 user stories
</commit_message>
<xml_diff>
--- a/docs/Slide_Bao_Cao_He_Thong_Dat_Lich_Salon_Spa.pptx
+++ b/docs/Slide_Bao_Cao_He_Thong_Dat_Lich_Salon_Spa.pptx
@@ -972,7 +972,7 @@
           <a:lstStyle/>
           <a:p>
             <a:r>
-              <a:t>Tóm lại, nhóm đã hoàn thành 39/39 story, giải quyết trực tiếp các vấn đề của cách quản lý thủ công. Hướng phát triển: thanh toán và đặt cọc trực tuyến, nhắc lịch qua Zalo/SMS, đa chi nhánh và CI/CD. Nhóm xin cảm ơn và sẵn sàng trả lời câu hỏi.</a:t>
+              <a:t>Nhóm đã đối chiếu 39/39 story với phạm vi đề tài, giải quyết các vấn đề của cách quản lý thủ công. Hướng phát triển: thanh toán và đặt cọc trực tuyến, nhắc lịch qua Zalo/SMS, đa chi nhánh và CI/CD. Nhóm xin cảm ơn và sẵn sàng trả lời câu hỏi.</a:t>
             </a:r>
           </a:p>
         </p:txBody>
@@ -10635,7 +10635,7 @@
                 </a:solidFill>
                 <a:latin typeface="Calibri"/>
               </a:rPr>
-              <a:t>Lập phiếu, mã NGAYTHUONG10 → 270.000 đ, đóng phiếu → email đánh giá</a:t>
+              <a:t>Lập phiếu, mã NGAYTHUONG10 → 963.000 đ, đóng phiếu → email đánh giá</a:t>
             </a:r>
           </a:p>
         </p:txBody>
@@ -11265,7 +11265,7 @@
                 </a:solidFill>
                 <a:latin typeface="Calibri"/>
               </a:rPr>
-              <a:t>Hoàn thành toàn bộ Product Backlog trong 4 Sprint</a:t>
+              <a:t>Đối chiếu đủ Product Backlog trong 4 Sprint</a:t>
             </a:r>
           </a:p>
         </p:txBody>
@@ -11567,7 +11567,7 @@
                 </a:solidFill>
                 <a:latin typeface="Calibri"/>
               </a:rPr>
-              <a:t>Phiếu khoá, nhật ký chỉ đọc, RBAC 5 vai trò</a:t>
+              <a:t>Phiếu khoá, nhật ký chỉ đọc, RBAC 4 vai trò nhân sự + khách</a:t>
             </a:r>
           </a:p>
         </p:txBody>
@@ -13599,9 +13599,770 @@
           <a:p/>
         </p:txBody>
       </p:sp>
+      <p:sp>
+        <p:nvSpPr>
+          <p:cNvPr id="5" name="Rounded Rectangle 4"/>
+          <p:cNvSpPr/>
+          <p:nvPr/>
+        </p:nvSpPr>
+        <p:spPr>
+          <a:xfrm>
+            <a:off x="777240" y="1755648"/>
+            <a:ext cx="6629400" cy="914400"/>
+          </a:xfrm>
+          <a:prstGeom prst="roundRect">
+            <a:avLst>
+              <a:gd name="adj" fmla="val 8000"/>
+            </a:avLst>
+          </a:prstGeom>
+          <a:solidFill>
+            <a:srgbClr val="F0FDFA"/>
+          </a:solidFill>
+          <a:ln>
+            <a:noFill/>
+          </a:ln>
+        </p:spPr>
+        <p:style>
+          <a:lnRef idx="1">
+            <a:schemeClr val="accent1"/>
+          </a:lnRef>
+          <a:fillRef idx="3">
+            <a:schemeClr val="accent1"/>
+          </a:fillRef>
+          <a:effectRef idx="2">
+            <a:schemeClr val="accent1"/>
+          </a:effectRef>
+          <a:fontRef idx="minor">
+            <a:schemeClr val="lt1"/>
+          </a:fontRef>
+        </p:style>
+        <p:txBody>
+          <a:bodyPr rtlCol="0" anchor="ctr"/>
+          <a:lstStyle/>
+          <a:p/>
+        </p:txBody>
+      </p:sp>
+      <p:sp>
+        <p:nvSpPr>
+          <p:cNvPr id="6" name="TextBox 5"/>
+          <p:cNvSpPr txBox="1"/>
+          <p:nvPr/>
+        </p:nvSpPr>
+        <p:spPr>
+          <a:xfrm>
+            <a:off x="960120" y="1847088"/>
+            <a:ext cx="2103120" cy="320040"/>
+          </a:xfrm>
+          <a:prstGeom prst="rect">
+            <a:avLst/>
+          </a:prstGeom>
+          <a:noFill/>
+        </p:spPr>
+        <p:txBody>
+          <a:bodyPr wrap="square" lIns="0" rIns="0" tIns="0" bIns="0" anchor="t">
+            <a:spAutoFit/>
+          </a:bodyPr>
+          <a:lstStyle/>
+          <a:p>
+            <a:pPr algn="l">
+              <a:lnSpc>
+                <a:spcPct val="108000"/>
+              </a:lnSpc>
+              <a:spcAft>
+                <a:spcPts val="400"/>
+              </a:spcAft>
+            </a:pPr>
+            <a:r>
+              <a:rPr sz="1600" b="1" i="0">
+                <a:solidFill>
+                  <a:srgbClr val="0F172A"/>
+                </a:solidFill>
+                <a:latin typeface="Calibri"/>
+              </a:rPr>
+              <a:t>1. Trình bày</a:t>
+            </a:r>
+          </a:p>
+        </p:txBody>
+      </p:sp>
+      <p:sp>
+        <p:nvSpPr>
+          <p:cNvPr id="7" name="TextBox 6"/>
+          <p:cNvSpPr txBox="1"/>
+          <p:nvPr/>
+        </p:nvSpPr>
+        <p:spPr>
+          <a:xfrm>
+            <a:off x="3108960" y="1828800"/>
+            <a:ext cx="3931920" cy="320040"/>
+          </a:xfrm>
+          <a:prstGeom prst="rect">
+            <a:avLst/>
+          </a:prstGeom>
+          <a:noFill/>
+        </p:spPr>
+        <p:txBody>
+          <a:bodyPr wrap="square" lIns="0" rIns="0" tIns="0" bIns="0" anchor="t">
+            <a:spAutoFit/>
+          </a:bodyPr>
+          <a:lstStyle/>
+          <a:p>
+            <a:pPr algn="l">
+              <a:lnSpc>
+                <a:spcPct val="108000"/>
+              </a:lnSpc>
+              <a:spcAft>
+                <a:spcPts val="400"/>
+              </a:spcAft>
+            </a:pPr>
+            <a:r>
+              <a:rPr sz="1400" b="1" i="0">
+                <a:solidFill>
+                  <a:srgbClr val="0F172A"/>
+                </a:solidFill>
+                <a:latin typeface="Calibri"/>
+              </a:rPr>
+              <a:t>React 18 + Vite</a:t>
+            </a:r>
+          </a:p>
+        </p:txBody>
+      </p:sp>
+      <p:sp>
+        <p:nvSpPr>
+          <p:cNvPr id="8" name="TextBox 7"/>
+          <p:cNvSpPr txBox="1"/>
+          <p:nvPr/>
+        </p:nvSpPr>
+        <p:spPr>
+          <a:xfrm>
+            <a:off x="960120" y="2194560"/>
+            <a:ext cx="6217920" cy="365760"/>
+          </a:xfrm>
+          <a:prstGeom prst="rect">
+            <a:avLst/>
+          </a:prstGeom>
+          <a:noFill/>
+        </p:spPr>
+        <p:txBody>
+          <a:bodyPr wrap="square" lIns="0" rIns="0" tIns="0" bIns="0" anchor="t">
+            <a:spAutoFit/>
+          </a:bodyPr>
+          <a:lstStyle/>
+          <a:p>
+            <a:pPr algn="l">
+              <a:lnSpc>
+                <a:spcPct val="108000"/>
+              </a:lnSpc>
+              <a:spcAft>
+                <a:spcPts val="400"/>
+              </a:spcAft>
+            </a:pPr>
+            <a:r>
+              <a:rPr sz="1300" b="0" i="0">
+                <a:solidFill>
+                  <a:srgbClr val="475569"/>
+                </a:solidFill>
+                <a:latin typeface="Calibri"/>
+              </a:rPr>
+              <a:t>Trang công khai và quản lý; nhận SSE để làm mới dữ liệu</a:t>
+            </a:r>
+          </a:p>
+        </p:txBody>
+      </p:sp>
+      <p:sp>
+        <p:nvSpPr>
+          <p:cNvPr id="9" name="Rounded Rectangle 8"/>
+          <p:cNvSpPr/>
+          <p:nvPr/>
+        </p:nvSpPr>
+        <p:spPr>
+          <a:xfrm>
+            <a:off x="777240" y="2788920"/>
+            <a:ext cx="6629400" cy="914400"/>
+          </a:xfrm>
+          <a:prstGeom prst="roundRect">
+            <a:avLst>
+              <a:gd name="adj" fmla="val 8000"/>
+            </a:avLst>
+          </a:prstGeom>
+          <a:solidFill>
+            <a:srgbClr val="F0FDFA"/>
+          </a:solidFill>
+          <a:ln>
+            <a:noFill/>
+          </a:ln>
+        </p:spPr>
+        <p:style>
+          <a:lnRef idx="1">
+            <a:schemeClr val="accent1"/>
+          </a:lnRef>
+          <a:fillRef idx="3">
+            <a:schemeClr val="accent1"/>
+          </a:fillRef>
+          <a:effectRef idx="2">
+            <a:schemeClr val="accent1"/>
+          </a:effectRef>
+          <a:fontRef idx="minor">
+            <a:schemeClr val="lt1"/>
+          </a:fontRef>
+        </p:style>
+        <p:txBody>
+          <a:bodyPr rtlCol="0" anchor="ctr"/>
+          <a:lstStyle/>
+          <a:p/>
+        </p:txBody>
+      </p:sp>
+      <p:sp>
+        <p:nvSpPr>
+          <p:cNvPr id="10" name="TextBox 9"/>
+          <p:cNvSpPr txBox="1"/>
+          <p:nvPr/>
+        </p:nvSpPr>
+        <p:spPr>
+          <a:xfrm>
+            <a:off x="960120" y="2880360"/>
+            <a:ext cx="2103120" cy="320040"/>
+          </a:xfrm>
+          <a:prstGeom prst="rect">
+            <a:avLst/>
+          </a:prstGeom>
+          <a:noFill/>
+        </p:spPr>
+        <p:txBody>
+          <a:bodyPr wrap="square" lIns="0" rIns="0" tIns="0" bIns="0" anchor="t">
+            <a:spAutoFit/>
+          </a:bodyPr>
+          <a:lstStyle/>
+          <a:p>
+            <a:pPr algn="l">
+              <a:lnSpc>
+                <a:spcPct val="108000"/>
+              </a:lnSpc>
+              <a:spcAft>
+                <a:spcPts val="400"/>
+              </a:spcAft>
+            </a:pPr>
+            <a:r>
+              <a:rPr sz="1600" b="1" i="0">
+                <a:solidFill>
+                  <a:srgbClr val="0F172A"/>
+                </a:solidFill>
+                <a:latin typeface="Calibri"/>
+              </a:rPr>
+              <a:t>2. Giao tiếp API</a:t>
+            </a:r>
+          </a:p>
+        </p:txBody>
+      </p:sp>
+      <p:sp>
+        <p:nvSpPr>
+          <p:cNvPr id="11" name="TextBox 10"/>
+          <p:cNvSpPr txBox="1"/>
+          <p:nvPr/>
+        </p:nvSpPr>
+        <p:spPr>
+          <a:xfrm>
+            <a:off x="3108960" y="2862072"/>
+            <a:ext cx="3931920" cy="320040"/>
+          </a:xfrm>
+          <a:prstGeom prst="rect">
+            <a:avLst/>
+          </a:prstGeom>
+          <a:noFill/>
+        </p:spPr>
+        <p:txBody>
+          <a:bodyPr wrap="square" lIns="0" rIns="0" tIns="0" bIns="0" anchor="t">
+            <a:spAutoFit/>
+          </a:bodyPr>
+          <a:lstStyle/>
+          <a:p>
+            <a:pPr algn="l">
+              <a:lnSpc>
+                <a:spcPct val="108000"/>
+              </a:lnSpc>
+              <a:spcAft>
+                <a:spcPts val="400"/>
+              </a:spcAft>
+            </a:pPr>
+            <a:r>
+              <a:rPr sz="1400" b="1" i="0">
+                <a:solidFill>
+                  <a:srgbClr val="0F172A"/>
+                </a:solidFill>
+                <a:latin typeface="Calibri"/>
+              </a:rPr>
+              <a:t>NestJS 10 Controller, DTO, Guard</a:t>
+            </a:r>
+          </a:p>
+        </p:txBody>
+      </p:sp>
+      <p:sp>
+        <p:nvSpPr>
+          <p:cNvPr id="12" name="TextBox 11"/>
+          <p:cNvSpPr txBox="1"/>
+          <p:nvPr/>
+        </p:nvSpPr>
+        <p:spPr>
+          <a:xfrm>
+            <a:off x="960120" y="3227832"/>
+            <a:ext cx="6217920" cy="365760"/>
+          </a:xfrm>
+          <a:prstGeom prst="rect">
+            <a:avLst/>
+          </a:prstGeom>
+          <a:noFill/>
+        </p:spPr>
+        <p:txBody>
+          <a:bodyPr wrap="square" lIns="0" rIns="0" tIns="0" bIns="0" anchor="t">
+            <a:spAutoFit/>
+          </a:bodyPr>
+          <a:lstStyle/>
+          <a:p>
+            <a:pPr algn="l">
+              <a:lnSpc>
+                <a:spcPct val="108000"/>
+              </a:lnSpc>
+              <a:spcAft>
+                <a:spcPts val="400"/>
+              </a:spcAft>
+            </a:pPr>
+            <a:r>
+              <a:rPr sz="1300" b="0" i="0">
+                <a:solidFill>
+                  <a:srgbClr val="475569"/>
+                </a:solidFill>
+                <a:latin typeface="Calibri"/>
+              </a:rPr>
+              <a:t>REST/JSON; xác thực JWT; kiểm tra dữ liệu và phân quyền</a:t>
+            </a:r>
+          </a:p>
+        </p:txBody>
+      </p:sp>
+      <p:sp>
+        <p:nvSpPr>
+          <p:cNvPr id="13" name="Rounded Rectangle 12"/>
+          <p:cNvSpPr/>
+          <p:nvPr/>
+        </p:nvSpPr>
+        <p:spPr>
+          <a:xfrm>
+            <a:off x="777240" y="3822191"/>
+            <a:ext cx="6629400" cy="914400"/>
+          </a:xfrm>
+          <a:prstGeom prst="roundRect">
+            <a:avLst>
+              <a:gd name="adj" fmla="val 8000"/>
+            </a:avLst>
+          </a:prstGeom>
+          <a:solidFill>
+            <a:srgbClr val="F0FDFA"/>
+          </a:solidFill>
+          <a:ln>
+            <a:noFill/>
+          </a:ln>
+        </p:spPr>
+        <p:style>
+          <a:lnRef idx="1">
+            <a:schemeClr val="accent1"/>
+          </a:lnRef>
+          <a:fillRef idx="3">
+            <a:schemeClr val="accent1"/>
+          </a:fillRef>
+          <a:effectRef idx="2">
+            <a:schemeClr val="accent1"/>
+          </a:effectRef>
+          <a:fontRef idx="minor">
+            <a:schemeClr val="lt1"/>
+          </a:fontRef>
+        </p:style>
+        <p:txBody>
+          <a:bodyPr rtlCol="0" anchor="ctr"/>
+          <a:lstStyle/>
+          <a:p/>
+        </p:txBody>
+      </p:sp>
+      <p:sp>
+        <p:nvSpPr>
+          <p:cNvPr id="14" name="TextBox 13"/>
+          <p:cNvSpPr txBox="1"/>
+          <p:nvPr/>
+        </p:nvSpPr>
+        <p:spPr>
+          <a:xfrm>
+            <a:off x="960120" y="3913631"/>
+            <a:ext cx="2103120" cy="320040"/>
+          </a:xfrm>
+          <a:prstGeom prst="rect">
+            <a:avLst/>
+          </a:prstGeom>
+          <a:noFill/>
+        </p:spPr>
+        <p:txBody>
+          <a:bodyPr wrap="square" lIns="0" rIns="0" tIns="0" bIns="0" anchor="t">
+            <a:spAutoFit/>
+          </a:bodyPr>
+          <a:lstStyle/>
+          <a:p>
+            <a:pPr algn="l">
+              <a:lnSpc>
+                <a:spcPct val="108000"/>
+              </a:lnSpc>
+              <a:spcAft>
+                <a:spcPts val="400"/>
+              </a:spcAft>
+            </a:pPr>
+            <a:r>
+              <a:rPr sz="1600" b="1" i="0">
+                <a:solidFill>
+                  <a:srgbClr val="0F172A"/>
+                </a:solidFill>
+                <a:latin typeface="Calibri"/>
+              </a:rPr>
+              <a:t>3. Nghiệp vụ</a:t>
+            </a:r>
+          </a:p>
+        </p:txBody>
+      </p:sp>
+      <p:sp>
+        <p:nvSpPr>
+          <p:cNvPr id="15" name="TextBox 14"/>
+          <p:cNvSpPr txBox="1"/>
+          <p:nvPr/>
+        </p:nvSpPr>
+        <p:spPr>
+          <a:xfrm>
+            <a:off x="3108960" y="3895343"/>
+            <a:ext cx="3931920" cy="320040"/>
+          </a:xfrm>
+          <a:prstGeom prst="rect">
+            <a:avLst/>
+          </a:prstGeom>
+          <a:noFill/>
+        </p:spPr>
+        <p:txBody>
+          <a:bodyPr wrap="square" lIns="0" rIns="0" tIns="0" bIns="0" anchor="t">
+            <a:spAutoFit/>
+          </a:bodyPr>
+          <a:lstStyle/>
+          <a:p>
+            <a:pPr algn="l">
+              <a:lnSpc>
+                <a:spcPct val="108000"/>
+              </a:lnSpc>
+              <a:spcAft>
+                <a:spcPts val="400"/>
+              </a:spcAft>
+            </a:pPr>
+            <a:r>
+              <a:rPr sz="1400" b="1" i="0">
+                <a:solidFill>
+                  <a:srgbClr val="0F172A"/>
+                </a:solidFill>
+                <a:latin typeface="Calibri"/>
+              </a:rPr>
+              <a:t>NestJS Service</a:t>
+            </a:r>
+          </a:p>
+        </p:txBody>
+      </p:sp>
+      <p:sp>
+        <p:nvSpPr>
+          <p:cNvPr id="16" name="TextBox 15"/>
+          <p:cNvSpPr txBox="1"/>
+          <p:nvPr/>
+        </p:nvSpPr>
+        <p:spPr>
+          <a:xfrm>
+            <a:off x="960120" y="4261103"/>
+            <a:ext cx="6217920" cy="365760"/>
+          </a:xfrm>
+          <a:prstGeom prst="rect">
+            <a:avLst/>
+          </a:prstGeom>
+          <a:noFill/>
+        </p:spPr>
+        <p:txBody>
+          <a:bodyPr wrap="square" lIns="0" rIns="0" tIns="0" bIns="0" anchor="t">
+            <a:spAutoFit/>
+          </a:bodyPr>
+          <a:lstStyle/>
+          <a:p>
+            <a:pPr algn="l">
+              <a:lnSpc>
+                <a:spcPct val="108000"/>
+              </a:lnSpc>
+              <a:spcAft>
+                <a:spcPts val="400"/>
+              </a:spcAft>
+            </a:pPr>
+            <a:r>
+              <a:rPr sz="1300" b="0" i="0">
+                <a:solidFill>
+                  <a:srgbClr val="475569"/>
+                </a:solidFill>
+                <a:latin typeface="Calibri"/>
+              </a:rPr>
+              <a:t>Tính khung giờ, ngày nghỉ, vòng đời lịch, thanh toán; phát sự kiện sau commit</a:t>
+            </a:r>
+          </a:p>
+        </p:txBody>
+      </p:sp>
+      <p:sp>
+        <p:nvSpPr>
+          <p:cNvPr id="17" name="Rounded Rectangle 16"/>
+          <p:cNvSpPr/>
+          <p:nvPr/>
+        </p:nvSpPr>
+        <p:spPr>
+          <a:xfrm>
+            <a:off x="777240" y="4855464"/>
+            <a:ext cx="6629400" cy="914400"/>
+          </a:xfrm>
+          <a:prstGeom prst="roundRect">
+            <a:avLst>
+              <a:gd name="adj" fmla="val 8000"/>
+            </a:avLst>
+          </a:prstGeom>
+          <a:solidFill>
+            <a:srgbClr val="F0FDFA"/>
+          </a:solidFill>
+          <a:ln>
+            <a:noFill/>
+          </a:ln>
+        </p:spPr>
+        <p:style>
+          <a:lnRef idx="1">
+            <a:schemeClr val="accent1"/>
+          </a:lnRef>
+          <a:fillRef idx="3">
+            <a:schemeClr val="accent1"/>
+          </a:fillRef>
+          <a:effectRef idx="2">
+            <a:schemeClr val="accent1"/>
+          </a:effectRef>
+          <a:fontRef idx="minor">
+            <a:schemeClr val="lt1"/>
+          </a:fontRef>
+        </p:style>
+        <p:txBody>
+          <a:bodyPr rtlCol="0" anchor="ctr"/>
+          <a:lstStyle/>
+          <a:p/>
+        </p:txBody>
+      </p:sp>
+      <p:sp>
+        <p:nvSpPr>
+          <p:cNvPr id="18" name="TextBox 17"/>
+          <p:cNvSpPr txBox="1"/>
+          <p:nvPr/>
+        </p:nvSpPr>
+        <p:spPr>
+          <a:xfrm>
+            <a:off x="960120" y="4946904"/>
+            <a:ext cx="2103120" cy="320040"/>
+          </a:xfrm>
+          <a:prstGeom prst="rect">
+            <a:avLst/>
+          </a:prstGeom>
+          <a:noFill/>
+        </p:spPr>
+        <p:txBody>
+          <a:bodyPr wrap="square" lIns="0" rIns="0" tIns="0" bIns="0" anchor="t">
+            <a:spAutoFit/>
+          </a:bodyPr>
+          <a:lstStyle/>
+          <a:p>
+            <a:pPr algn="l">
+              <a:lnSpc>
+                <a:spcPct val="108000"/>
+              </a:lnSpc>
+              <a:spcAft>
+                <a:spcPts val="400"/>
+              </a:spcAft>
+            </a:pPr>
+            <a:r>
+              <a:rPr sz="1600" b="1" i="0">
+                <a:solidFill>
+                  <a:srgbClr val="0F172A"/>
+                </a:solidFill>
+                <a:latin typeface="Calibri"/>
+              </a:rPr>
+              <a:t>4. Lưu trữ</a:t>
+            </a:r>
+          </a:p>
+        </p:txBody>
+      </p:sp>
+      <p:sp>
+        <p:nvSpPr>
+          <p:cNvPr id="19" name="TextBox 18"/>
+          <p:cNvSpPr txBox="1"/>
+          <p:nvPr/>
+        </p:nvSpPr>
+        <p:spPr>
+          <a:xfrm>
+            <a:off x="3108960" y="4928616"/>
+            <a:ext cx="3931920" cy="320040"/>
+          </a:xfrm>
+          <a:prstGeom prst="rect">
+            <a:avLst/>
+          </a:prstGeom>
+          <a:noFill/>
+        </p:spPr>
+        <p:txBody>
+          <a:bodyPr wrap="square" lIns="0" rIns="0" tIns="0" bIns="0" anchor="t">
+            <a:spAutoFit/>
+          </a:bodyPr>
+          <a:lstStyle/>
+          <a:p>
+            <a:pPr algn="l">
+              <a:lnSpc>
+                <a:spcPct val="108000"/>
+              </a:lnSpc>
+              <a:spcAft>
+                <a:spcPts val="400"/>
+              </a:spcAft>
+            </a:pPr>
+            <a:r>
+              <a:rPr sz="1400" b="1" i="0">
+                <a:solidFill>
+                  <a:srgbClr val="0F172A"/>
+                </a:solidFill>
+                <a:latin typeface="Calibri"/>
+              </a:rPr>
+              <a:t>TypeORM Repository + PostgreSQL</a:t>
+            </a:r>
+          </a:p>
+        </p:txBody>
+      </p:sp>
+      <p:sp>
+        <p:nvSpPr>
+          <p:cNvPr id="20" name="TextBox 19"/>
+          <p:cNvSpPr txBox="1"/>
+          <p:nvPr/>
+        </p:nvSpPr>
+        <p:spPr>
+          <a:xfrm>
+            <a:off x="960120" y="5294376"/>
+            <a:ext cx="6217920" cy="365760"/>
+          </a:xfrm>
+          <a:prstGeom prst="rect">
+            <a:avLst/>
+          </a:prstGeom>
+          <a:noFill/>
+        </p:spPr>
+        <p:txBody>
+          <a:bodyPr wrap="square" lIns="0" rIns="0" tIns="0" bIns="0" anchor="t">
+            <a:spAutoFit/>
+          </a:bodyPr>
+          <a:lstStyle/>
+          <a:p>
+            <a:pPr algn="l">
+              <a:lnSpc>
+                <a:spcPct val="108000"/>
+              </a:lnSpc>
+              <a:spcAft>
+                <a:spcPts val="400"/>
+              </a:spcAft>
+            </a:pPr>
+            <a:r>
+              <a:rPr sz="1300" b="0" i="0">
+                <a:solidFill>
+                  <a:srgbClr val="475569"/>
+                </a:solidFill>
+                <a:latin typeface="Calibri"/>
+              </a:rPr>
+              <a:t>Migration có phiên bản; giao dịch SERIALIZABLE, FOR UPDATE, EXCLUDE</a:t>
+            </a:r>
+          </a:p>
+        </p:txBody>
+      </p:sp>
+      <p:sp>
+        <p:nvSpPr>
+          <p:cNvPr id="21" name="TextBox 20"/>
+          <p:cNvSpPr txBox="1"/>
+          <p:nvPr/>
+        </p:nvSpPr>
+        <p:spPr>
+          <a:xfrm>
+            <a:off x="960120" y="5897880"/>
+            <a:ext cx="6400800" cy="274320"/>
+          </a:xfrm>
+          <a:prstGeom prst="rect">
+            <a:avLst/>
+          </a:prstGeom>
+          <a:noFill/>
+        </p:spPr>
+        <p:txBody>
+          <a:bodyPr wrap="square" lIns="0" rIns="0" tIns="0" bIns="0" anchor="t">
+            <a:spAutoFit/>
+          </a:bodyPr>
+          <a:lstStyle/>
+          <a:p>
+            <a:pPr algn="l">
+              <a:lnSpc>
+                <a:spcPct val="108000"/>
+              </a:lnSpc>
+              <a:spcAft>
+                <a:spcPts val="400"/>
+              </a:spcAft>
+            </a:pPr>
+            <a:r>
+              <a:rPr sz="1300" b="0" i="0">
+                <a:solidFill>
+                  <a:srgbClr val="0F766E"/>
+                </a:solidFill>
+                <a:latin typeface="Calibri"/>
+              </a:rPr>
+              <a:t>SSE sau commit · Migration có phiên bản · cập nhật một chạm</a:t>
+            </a:r>
+          </a:p>
+        </p:txBody>
+      </p:sp>
+      <p:sp>
+        <p:nvSpPr>
+          <p:cNvPr id="22" name="Oval 21"/>
+          <p:cNvSpPr/>
+          <p:nvPr/>
+        </p:nvSpPr>
+        <p:spPr>
+          <a:xfrm>
+            <a:off x="8092440" y="1600200"/>
+            <a:ext cx="512064" cy="512064"/>
+          </a:xfrm>
+          <a:prstGeom prst="ellipse">
+            <a:avLst/>
+          </a:prstGeom>
+          <a:solidFill>
+            <a:srgbClr val="0D9488"/>
+          </a:solidFill>
+          <a:ln>
+            <a:noFill/>
+          </a:ln>
+        </p:spPr>
+        <p:style>
+          <a:lnRef idx="1">
+            <a:schemeClr val="accent1"/>
+          </a:lnRef>
+          <a:fillRef idx="3">
+            <a:schemeClr val="accent1"/>
+          </a:fillRef>
+          <a:effectRef idx="2">
+            <a:schemeClr val="accent1"/>
+          </a:effectRef>
+          <a:fontRef idx="minor">
+            <a:schemeClr val="lt1"/>
+          </a:fontRef>
+        </p:style>
+        <p:txBody>
+          <a:bodyPr rtlCol="0" anchor="ctr"/>
+          <a:lstStyle/>
+          <a:p>
+            <a:pPr algn="ctr"/>
+          </a:p>
+        </p:txBody>
+      </p:sp>
       <p:pic>
         <p:nvPicPr>
-          <p:cNvPr id="5" name="Picture 4" descr="arch.png"/>
+          <p:cNvPr id="23" name="Picture 22" descr="layers_w.png"/>
           <p:cNvPicPr>
             <a:picLocks noChangeAspect="1"/>
           </p:cNvPicPr>
@@ -13615,8 +14376,8 @@
         </p:blipFill>
         <p:spPr>
           <a:xfrm>
-            <a:off x="1023918" y="1691640"/>
-            <a:ext cx="6273204" cy="4389120"/>
+            <a:off x="8215335" y="1723095"/>
+            <a:ext cx="266274" cy="266274"/>
           </a:xfrm>
           <a:prstGeom prst="rect">
             <a:avLst/>
@@ -13625,13 +14386,97 @@
       </p:pic>
       <p:sp>
         <p:nvSpPr>
-          <p:cNvPr id="6" name="Oval 5"/>
+          <p:cNvPr id="24" name="TextBox 23"/>
+          <p:cNvSpPr txBox="1"/>
+          <p:nvPr/>
+        </p:nvSpPr>
+        <p:spPr>
+          <a:xfrm>
+            <a:off x="8778240" y="1581912"/>
+            <a:ext cx="3017520" cy="320040"/>
+          </a:xfrm>
+          <a:prstGeom prst="rect">
+            <a:avLst/>
+          </a:prstGeom>
+          <a:noFill/>
+        </p:spPr>
+        <p:txBody>
+          <a:bodyPr wrap="square" lIns="0" rIns="0" tIns="0" bIns="0" anchor="t">
+            <a:spAutoFit/>
+          </a:bodyPr>
+          <a:lstStyle/>
+          <a:p>
+            <a:pPr algn="l">
+              <a:lnSpc>
+                <a:spcPct val="108000"/>
+              </a:lnSpc>
+              <a:spcAft>
+                <a:spcPts val="400"/>
+              </a:spcAft>
+            </a:pPr>
+            <a:r>
+              <a:rPr sz="1600" b="1" i="0">
+                <a:solidFill>
+                  <a:srgbClr val="0F172A"/>
+                </a:solidFill>
+                <a:latin typeface="Calibri"/>
+              </a:rPr>
+              <a:t>Controller – Service – Repository</a:t>
+            </a:r>
+          </a:p>
+        </p:txBody>
+      </p:sp>
+      <p:sp>
+        <p:nvSpPr>
+          <p:cNvPr id="25" name="TextBox 24"/>
+          <p:cNvSpPr txBox="1"/>
+          <p:nvPr/>
+        </p:nvSpPr>
+        <p:spPr>
+          <a:xfrm>
+            <a:off x="8778240" y="1929384"/>
+            <a:ext cx="3017520" cy="685800"/>
+          </a:xfrm>
+          <a:prstGeom prst="rect">
+            <a:avLst/>
+          </a:prstGeom>
+          <a:noFill/>
+        </p:spPr>
+        <p:txBody>
+          <a:bodyPr wrap="square" lIns="0" rIns="0" tIns="0" bIns="0" anchor="t">
+            <a:spAutoFit/>
+          </a:bodyPr>
+          <a:lstStyle/>
+          <a:p>
+            <a:pPr algn="l">
+              <a:lnSpc>
+                <a:spcPct val="108000"/>
+              </a:lnSpc>
+              <a:spcAft>
+                <a:spcPts val="400"/>
+              </a:spcAft>
+            </a:pPr>
+            <a:r>
+              <a:rPr sz="1300" b="0" i="0">
+                <a:solidFill>
+                  <a:srgbClr val="475569"/>
+                </a:solidFill>
+                <a:latin typeface="Calibri"/>
+              </a:rPr>
+              <a:t>API và nghiệp vụ NestJS 10; TypeORM Migration; Swagger /api/docs</a:t>
+            </a:r>
+          </a:p>
+        </p:txBody>
+      </p:sp>
+      <p:sp>
+        <p:nvSpPr>
+          <p:cNvPr id="26" name="Oval 25"/>
           <p:cNvSpPr/>
           <p:nvPr/>
         </p:nvSpPr>
         <p:spPr>
           <a:xfrm>
-            <a:off x="8092440" y="1600200"/>
+            <a:off x="8092440" y="2761488"/>
             <a:ext cx="512064" cy="512064"/>
           </a:xfrm>
           <a:prstGeom prst="ellipse">
@@ -13668,7 +14513,7 @@
       </p:sp>
       <p:pic>
         <p:nvPicPr>
-          <p:cNvPr id="7" name="Picture 6" descr="layers_w.png"/>
+          <p:cNvPr id="27" name="Picture 26" descr="shield_w.png"/>
           <p:cNvPicPr>
             <a:picLocks noChangeAspect="1"/>
           </p:cNvPicPr>
@@ -13682,7 +14527,7 @@
         </p:blipFill>
         <p:spPr>
           <a:xfrm>
-            <a:off x="8215335" y="1723095"/>
+            <a:off x="8215335" y="2884383"/>
             <a:ext cx="266274" cy="266274"/>
           </a:xfrm>
           <a:prstGeom prst="rect">
@@ -13692,13 +14537,13 @@
       </p:pic>
       <p:sp>
         <p:nvSpPr>
-          <p:cNvPr id="8" name="TextBox 7"/>
-          <p:cNvSpPr txBox="1"/>
-          <p:nvPr/>
-        </p:nvSpPr>
-        <p:spPr>
-          <a:xfrm>
-            <a:off x="8778240" y="1581912"/>
+          <p:cNvPr id="28" name="TextBox 27"/>
+          <p:cNvSpPr txBox="1"/>
+          <p:nvPr/>
+        </p:nvSpPr>
+        <p:spPr>
+          <a:xfrm>
+            <a:off x="8778240" y="2743200"/>
             <a:ext cx="3017520" cy="320040"/>
           </a:xfrm>
           <a:prstGeom prst="rect">
@@ -13727,20 +14572,20 @@
                 </a:solidFill>
                 <a:latin typeface="Calibri"/>
               </a:rPr>
-              <a:t>Controller – Service – Repository</a:t>
-            </a:r>
-          </a:p>
-        </p:txBody>
-      </p:sp>
-      <p:sp>
-        <p:nvSpPr>
-          <p:cNvPr id="9" name="TextBox 8"/>
-          <p:cNvSpPr txBox="1"/>
-          <p:nvPr/>
-        </p:nvSpPr>
-        <p:spPr>
-          <a:xfrm>
-            <a:off x="8778240" y="1929384"/>
+              <a:t>Guard toàn cục</a:t>
+            </a:r>
+          </a:p>
+        </p:txBody>
+      </p:sp>
+      <p:sp>
+        <p:nvSpPr>
+          <p:cNvPr id="29" name="TextBox 28"/>
+          <p:cNvSpPr txBox="1"/>
+          <p:nvPr/>
+        </p:nvSpPr>
+        <p:spPr>
+          <a:xfrm>
+            <a:off x="8778240" y="3090672"/>
             <a:ext cx="3017520" cy="685800"/>
           </a:xfrm>
           <a:prstGeom prst="rect">
@@ -13769,20 +14614,20 @@
                 </a:solidFill>
                 <a:latin typeface="Calibri"/>
               </a:rPr>
-              <a:t>API và nghiệp vụ NestJS 10; TypeORM Migration; Swagger /api/docs</a:t>
-            </a:r>
-          </a:p>
-        </p:txBody>
-      </p:sp>
-      <p:sp>
-        <p:nvSpPr>
-          <p:cNvPr id="10" name="Oval 9"/>
+              <a:t>JWT + RBAC 4 vai trò nhân sự; khách dùng API công khai</a:t>
+            </a:r>
+          </a:p>
+        </p:txBody>
+      </p:sp>
+      <p:sp>
+        <p:nvSpPr>
+          <p:cNvPr id="30" name="Oval 29"/>
           <p:cNvSpPr/>
           <p:nvPr/>
         </p:nvSpPr>
         <p:spPr>
           <a:xfrm>
-            <a:off x="8092440" y="2761488"/>
+            <a:off x="8092440" y="3922776"/>
             <a:ext cx="512064" cy="512064"/>
           </a:xfrm>
           <a:prstGeom prst="ellipse">
@@ -13819,7 +14664,7 @@
       </p:sp>
       <p:pic>
         <p:nvPicPr>
-          <p:cNvPr id="11" name="Picture 10" descr="shield_w.png"/>
+          <p:cNvPr id="31" name="Picture 30" descr="server_w.png"/>
           <p:cNvPicPr>
             <a:picLocks noChangeAspect="1"/>
           </p:cNvPicPr>
@@ -13833,7 +14678,7 @@
         </p:blipFill>
         <p:spPr>
           <a:xfrm>
-            <a:off x="8215335" y="2884383"/>
+            <a:off x="8215335" y="4045671"/>
             <a:ext cx="266274" cy="266274"/>
           </a:xfrm>
           <a:prstGeom prst="rect">
@@ -13843,13 +14688,13 @@
       </p:pic>
       <p:sp>
         <p:nvSpPr>
-          <p:cNvPr id="12" name="TextBox 11"/>
-          <p:cNvSpPr txBox="1"/>
-          <p:nvPr/>
-        </p:nvSpPr>
-        <p:spPr>
-          <a:xfrm>
-            <a:off x="8778240" y="2743200"/>
+          <p:cNvPr id="32" name="TextBox 31"/>
+          <p:cNvSpPr txBox="1"/>
+          <p:nvPr/>
+        </p:nvSpPr>
+        <p:spPr>
+          <a:xfrm>
+            <a:off x="8778240" y="3904488"/>
             <a:ext cx="3017520" cy="320040"/>
           </a:xfrm>
           <a:prstGeom prst="rect">
@@ -13878,20 +14723,20 @@
                 </a:solidFill>
                 <a:latin typeface="Calibri"/>
               </a:rPr>
-              <a:t>Guard toàn cục</a:t>
-            </a:r>
-          </a:p>
-        </p:txBody>
-      </p:sp>
-      <p:sp>
-        <p:nvSpPr>
-          <p:cNvPr id="13" name="TextBox 12"/>
-          <p:cNvSpPr txBox="1"/>
-          <p:nvPr/>
-        </p:nvSpPr>
-        <p:spPr>
-          <a:xfrm>
-            <a:off x="8778240" y="3090672"/>
+              <a:t>Ràng buộc ở tầng CSDL</a:t>
+            </a:r>
+          </a:p>
+        </p:txBody>
+      </p:sp>
+      <p:sp>
+        <p:nvSpPr>
+          <p:cNvPr id="33" name="TextBox 32"/>
+          <p:cNvSpPr txBox="1"/>
+          <p:nvPr/>
+        </p:nvSpPr>
+        <p:spPr>
+          <a:xfrm>
+            <a:off x="8778240" y="4251960"/>
             <a:ext cx="3017520" cy="685800"/>
           </a:xfrm>
           <a:prstGeom prst="rect">
@@ -13920,20 +14765,20 @@
                 </a:solidFill>
                 <a:latin typeface="Calibri"/>
               </a:rPr>
-              <a:t>JWT + RBAC 4 vai trò nhân sự; khách dùng API công khai</a:t>
-            </a:r>
-          </a:p>
-        </p:txBody>
-      </p:sp>
-      <p:sp>
-        <p:nvSpPr>
-          <p:cNvPr id="14" name="Oval 13"/>
+              <a:t>24 bảng, EXCLUDE, CHECK, trigger nhật ký chỉ đọc</a:t>
+            </a:r>
+          </a:p>
+        </p:txBody>
+      </p:sp>
+      <p:sp>
+        <p:nvSpPr>
+          <p:cNvPr id="34" name="Oval 33"/>
           <p:cNvSpPr/>
           <p:nvPr/>
         </p:nvSpPr>
         <p:spPr>
           <a:xfrm>
-            <a:off x="8092440" y="3922776"/>
+            <a:off x="8092440" y="5084064"/>
             <a:ext cx="512064" cy="512064"/>
           </a:xfrm>
           <a:prstGeom prst="ellipse">
@@ -13970,7 +14815,7 @@
       </p:sp>
       <p:pic>
         <p:nvPicPr>
-          <p:cNvPr id="15" name="Picture 14" descr="server_w.png"/>
+          <p:cNvPr id="35" name="Picture 34" descr="calendar_w.png"/>
           <p:cNvPicPr>
             <a:picLocks noChangeAspect="1"/>
           </p:cNvPicPr>
@@ -13984,157 +14829,6 @@
         </p:blipFill>
         <p:spPr>
           <a:xfrm>
-            <a:off x="8215335" y="4045671"/>
-            <a:ext cx="266274" cy="266274"/>
-          </a:xfrm>
-          <a:prstGeom prst="rect">
-            <a:avLst/>
-          </a:prstGeom>
-        </p:spPr>
-      </p:pic>
-      <p:sp>
-        <p:nvSpPr>
-          <p:cNvPr id="16" name="TextBox 15"/>
-          <p:cNvSpPr txBox="1"/>
-          <p:nvPr/>
-        </p:nvSpPr>
-        <p:spPr>
-          <a:xfrm>
-            <a:off x="8778240" y="3904488"/>
-            <a:ext cx="3017520" cy="320040"/>
-          </a:xfrm>
-          <a:prstGeom prst="rect">
-            <a:avLst/>
-          </a:prstGeom>
-          <a:noFill/>
-        </p:spPr>
-        <p:txBody>
-          <a:bodyPr wrap="square" lIns="0" rIns="0" tIns="0" bIns="0" anchor="t">
-            <a:spAutoFit/>
-          </a:bodyPr>
-          <a:lstStyle/>
-          <a:p>
-            <a:pPr algn="l">
-              <a:lnSpc>
-                <a:spcPct val="108000"/>
-              </a:lnSpc>
-              <a:spcAft>
-                <a:spcPts val="400"/>
-              </a:spcAft>
-            </a:pPr>
-            <a:r>
-              <a:rPr sz="1600" b="1" i="0">
-                <a:solidFill>
-                  <a:srgbClr val="0F172A"/>
-                </a:solidFill>
-                <a:latin typeface="Calibri"/>
-              </a:rPr>
-              <a:t>Ràng buộc ở tầng CSDL</a:t>
-            </a:r>
-          </a:p>
-        </p:txBody>
-      </p:sp>
-      <p:sp>
-        <p:nvSpPr>
-          <p:cNvPr id="17" name="TextBox 16"/>
-          <p:cNvSpPr txBox="1"/>
-          <p:nvPr/>
-        </p:nvSpPr>
-        <p:spPr>
-          <a:xfrm>
-            <a:off x="8778240" y="4251960"/>
-            <a:ext cx="3017520" cy="685800"/>
-          </a:xfrm>
-          <a:prstGeom prst="rect">
-            <a:avLst/>
-          </a:prstGeom>
-          <a:noFill/>
-        </p:spPr>
-        <p:txBody>
-          <a:bodyPr wrap="square" lIns="0" rIns="0" tIns="0" bIns="0" anchor="t">
-            <a:spAutoFit/>
-          </a:bodyPr>
-          <a:lstStyle/>
-          <a:p>
-            <a:pPr algn="l">
-              <a:lnSpc>
-                <a:spcPct val="108000"/>
-              </a:lnSpc>
-              <a:spcAft>
-                <a:spcPts val="400"/>
-              </a:spcAft>
-            </a:pPr>
-            <a:r>
-              <a:rPr sz="1300" b="0" i="0">
-                <a:solidFill>
-                  <a:srgbClr val="475569"/>
-                </a:solidFill>
-                <a:latin typeface="Calibri"/>
-              </a:rPr>
-              <a:t>24 bảng, EXCLUDE, CHECK, trigger nhật ký chỉ đọc</a:t>
-            </a:r>
-          </a:p>
-        </p:txBody>
-      </p:sp>
-      <p:sp>
-        <p:nvSpPr>
-          <p:cNvPr id="18" name="Oval 17"/>
-          <p:cNvSpPr/>
-          <p:nvPr/>
-        </p:nvSpPr>
-        <p:spPr>
-          <a:xfrm>
-            <a:off x="8092440" y="5084064"/>
-            <a:ext cx="512064" cy="512064"/>
-          </a:xfrm>
-          <a:prstGeom prst="ellipse">
-            <a:avLst/>
-          </a:prstGeom>
-          <a:solidFill>
-            <a:srgbClr val="0D9488"/>
-          </a:solidFill>
-          <a:ln>
-            <a:noFill/>
-          </a:ln>
-        </p:spPr>
-        <p:style>
-          <a:lnRef idx="1">
-            <a:schemeClr val="accent1"/>
-          </a:lnRef>
-          <a:fillRef idx="3">
-            <a:schemeClr val="accent1"/>
-          </a:fillRef>
-          <a:effectRef idx="2">
-            <a:schemeClr val="accent1"/>
-          </a:effectRef>
-          <a:fontRef idx="minor">
-            <a:schemeClr val="lt1"/>
-          </a:fontRef>
-        </p:style>
-        <p:txBody>
-          <a:bodyPr rtlCol="0" anchor="ctr"/>
-          <a:lstStyle/>
-          <a:p>
-            <a:pPr algn="ctr"/>
-          </a:p>
-        </p:txBody>
-      </p:sp>
-      <p:pic>
-        <p:nvPicPr>
-          <p:cNvPr id="19" name="Picture 18" descr="calendar_w.png"/>
-          <p:cNvPicPr>
-            <a:picLocks noChangeAspect="1"/>
-          </p:cNvPicPr>
-          <p:nvPr/>
-        </p:nvPicPr>
-        <p:blipFill>
-          <a:blip r:embed="rId6"/>
-          <a:stretch>
-            <a:fillRect/>
-          </a:stretch>
-        </p:blipFill>
-        <p:spPr>
-          <a:xfrm>
             <a:off x="8215335" y="5206959"/>
             <a:ext cx="266274" cy="266274"/>
           </a:xfrm>
@@ -14145,7 +14839,7 @@
       </p:pic>
       <p:sp>
         <p:nvSpPr>
-          <p:cNvPr id="20" name="TextBox 19"/>
+          <p:cNvPr id="36" name="TextBox 35"/>
           <p:cNvSpPr txBox="1"/>
           <p:nvPr/>
         </p:nvSpPr>
@@ -14187,7 +14881,7 @@
       </p:sp>
       <p:sp>
         <p:nvSpPr>
-          <p:cNvPr id="21" name="TextBox 20"/>
+          <p:cNvPr id="37" name="TextBox 36"/>
           <p:cNvSpPr txBox="1"/>
           <p:nvPr/>
         </p:nvSpPr>
@@ -14229,7 +14923,7 @@
       </p:sp>
       <p:sp>
         <p:nvSpPr>
-          <p:cNvPr id="22" name="TextBox 21"/>
+          <p:cNvPr id="38" name="TextBox 37"/>
           <p:cNvSpPr txBox="1"/>
           <p:nvPr/>
         </p:nvSpPr>
@@ -14271,7 +14965,7 @@
       </p:sp>
       <p:sp>
         <p:nvSpPr>
-          <p:cNvPr id="23" name="TextBox 22"/>
+          <p:cNvPr id="39" name="TextBox 38"/>
           <p:cNvSpPr txBox="1"/>
           <p:nvPr/>
         </p:nvSpPr>

</xml_diff>